<commit_message>
feat: add tenant data studio and redesign dashboard
</commit_message>
<xml_diff>
--- a/docs/slides/ChainMind_Pitch_EN.pptx
+++ b/docs/slides/ChainMind_Pitch_EN.pptx
@@ -4761,7 +4761,7 @@
               </a:defRPr>
             </a:pPr>
             <a:r>
-              <a:t>• Backend 155 passed / 9 skipped; Vitest 15 passed; Playwright 10 passed.</a:t>
+              <a:t>• Backend 163 passed / 9 skipped; Vitest 18 passed; Playwright 11 passed.</a:t>
             </a:r>
           </a:p>
           <a:p>
@@ -5431,8 +5431,8 @@
         </p:blipFill>
         <p:spPr>
           <a:xfrm>
-            <a:off x="7734787" y="1965960"/>
-            <a:ext cx="3092744" cy="4114800"/>
+            <a:off x="6995160" y="2737485"/>
+            <a:ext cx="4572000" cy="2571750"/>
           </a:xfrm>
           <a:prstGeom prst="rect">
             <a:avLst/>
@@ -5895,7 +5895,7 @@
       </p:sp>
       <p:pic>
         <p:nvPicPr>
-          <p:cNvPr id="5" name="Picture 4" descr="po-approval.png"/>
+          <p:cNvPr id="5" name="Picture 4" descr="dashboard-en-light.png"/>
           <p:cNvPicPr>
             <a:picLocks noChangeAspect="1"/>
           </p:cNvPicPr>
@@ -5909,8 +5909,8 @@
         </p:blipFill>
         <p:spPr>
           <a:xfrm>
-            <a:off x="8442686" y="1965960"/>
-            <a:ext cx="1676947" cy="4114800"/>
+            <a:off x="6995160" y="2737485"/>
+            <a:ext cx="4572000" cy="2571750"/>
           </a:xfrm>
           <a:prstGeom prst="rect">
             <a:avLst/>
@@ -6144,8 +6144,8 @@
         </p:blipFill>
         <p:spPr>
           <a:xfrm>
-            <a:off x="6995160" y="3718810"/>
-            <a:ext cx="4572000" cy="609098"/>
+            <a:off x="6995160" y="3705859"/>
+            <a:ext cx="4572000" cy="635000"/>
           </a:xfrm>
           <a:prstGeom prst="rect">
             <a:avLst/>

</xml_diff>

<commit_message>
feat: polish entry experience and release v1.1.1
</commit_message>
<xml_diff>
--- a/docs/slides/ChainMind_Pitch_EN.pptx
+++ b/docs/slides/ChainMind_Pitch_EN.pptx
@@ -4314,7 +4314,7 @@
         <p:spPr>
           <a:xfrm>
             <a:off x="822960" y="1554480"/>
-            <a:ext cx="10424160" cy="4480560"/>
+            <a:ext cx="5760720" cy="4480560"/>
           </a:xfrm>
           <a:prstGeom prst="rect">
             <a:avLst/>
@@ -4360,9 +4360,33 @@
           </a:p>
         </p:txBody>
       </p:sp>
-      <p:sp>
-        <p:nvSpPr>
-          <p:cNvPr id="5" name="TextBox 4"/>
+      <p:pic>
+        <p:nvPicPr>
+          <p:cNvPr id="5" name="Picture 4" descr="welcome-en-light.png"/>
+          <p:cNvPicPr>
+            <a:picLocks noChangeAspect="1"/>
+          </p:cNvPicPr>
+          <p:nvPr/>
+        </p:nvPicPr>
+        <p:blipFill>
+          <a:blip r:embed="rId2"/>
+          <a:stretch>
+            <a:fillRect/>
+          </a:stretch>
+        </p:blipFill>
+        <p:spPr>
+          <a:xfrm>
+            <a:off x="6995160" y="2737485"/>
+            <a:ext cx="4572000" cy="2571750"/>
+          </a:xfrm>
+          <a:prstGeom prst="rect">
+            <a:avLst/>
+          </a:prstGeom>
+        </p:spPr>
+      </p:pic>
+      <p:sp>
+        <p:nvSpPr>
+          <p:cNvPr id="6" name="TextBox 5"/>
           <p:cNvSpPr txBox="1"/>
           <p:nvPr/>
         </p:nvSpPr>
@@ -4761,7 +4785,7 @@
               </a:defRPr>
             </a:pPr>
             <a:r>
-              <a:t>• Backend 163 passed / 9 skipped; Vitest 18 passed; Playwright 11 passed.</a:t>
+              <a:t>• Current validation results and boundaries are recorded in docs/COVERAGE.md.</a:t>
             </a:r>
           </a:p>
           <a:p>
@@ -4931,7 +4955,7 @@
         <p:spPr>
           <a:xfrm>
             <a:off x="822960" y="1554480"/>
-            <a:ext cx="10424160" cy="4480560"/>
+            <a:ext cx="5760720" cy="4480560"/>
           </a:xfrm>
           <a:prstGeom prst="rect">
             <a:avLst/>
@@ -4993,9 +5017,33 @@
           </a:p>
         </p:txBody>
       </p:sp>
-      <p:sp>
-        <p:nvSpPr>
-          <p:cNvPr id="5" name="TextBox 4"/>
+      <p:pic>
+        <p:nvPicPr>
+          <p:cNvPr id="5" name="Picture 4" descr="login-en-light.png"/>
+          <p:cNvPicPr>
+            <a:picLocks noChangeAspect="1"/>
+          </p:cNvPicPr>
+          <p:nvPr/>
+        </p:nvPicPr>
+        <p:blipFill>
+          <a:blip r:embed="rId2"/>
+          <a:stretch>
+            <a:fillRect/>
+          </a:stretch>
+        </p:blipFill>
+        <p:spPr>
+          <a:xfrm>
+            <a:off x="6995160" y="2737485"/>
+            <a:ext cx="4572000" cy="2571750"/>
+          </a:xfrm>
+          <a:prstGeom prst="rect">
+            <a:avLst/>
+          </a:prstGeom>
+        </p:spPr>
+      </p:pic>
+      <p:sp>
+        <p:nvSpPr>
+          <p:cNvPr id="6" name="TextBox 5"/>
           <p:cNvSpPr txBox="1"/>
           <p:nvPr/>
         </p:nvSpPr>
@@ -5142,7 +5190,7 @@
         <p:spPr>
           <a:xfrm>
             <a:off x="822960" y="1554480"/>
-            <a:ext cx="10424160" cy="4480560"/>
+            <a:ext cx="5760720" cy="4480560"/>
           </a:xfrm>
           <a:prstGeom prst="rect">
             <a:avLst/>
@@ -5204,9 +5252,33 @@
           </a:p>
         </p:txBody>
       </p:sp>
-      <p:sp>
-        <p:nvSpPr>
-          <p:cNvPr id="5" name="TextBox 4"/>
+      <p:pic>
+        <p:nvPicPr>
+          <p:cNvPr id="5" name="Picture 4" descr="idp-en-light.png"/>
+          <p:cNvPicPr>
+            <a:picLocks noChangeAspect="1"/>
+          </p:cNvPicPr>
+          <p:nvPr/>
+        </p:nvPicPr>
+        <p:blipFill>
+          <a:blip r:embed="rId2"/>
+          <a:stretch>
+            <a:fillRect/>
+          </a:stretch>
+        </p:blipFill>
+        <p:spPr>
+          <a:xfrm>
+            <a:off x="6995160" y="2737485"/>
+            <a:ext cx="4572000" cy="2571750"/>
+          </a:xfrm>
+          <a:prstGeom prst="rect">
+            <a:avLst/>
+          </a:prstGeom>
+        </p:spPr>
+      </p:pic>
+      <p:sp>
+        <p:nvSpPr>
+          <p:cNvPr id="6" name="TextBox 5"/>
           <p:cNvSpPr txBox="1"/>
           <p:nvPr/>
         </p:nvSpPr>

</xml_diff>